<commit_message>
Match banner tagline width to LazyingArt wordmark
</commit_message>
<xml_diff>
--- a/logos/brand/LazyingArt-banner.pptx
+++ b/logos/brand/LazyingArt-banner.pptx
@@ -2,13 +2,13 @@
 <file path=ppt/presentation.xml><?xml version="1.0" encoding="utf-8"?>
 <p:presentation xmlns:p="http://schemas.openxmlformats.org/presentationml/2006/main">
   <p:sldMasterIdLst>
-    <p:sldMasterId xmlns:r="http://schemas.openxmlformats.org/officeDocument/2006/relationships" id="2147483648" r:id="R7c662cab1bd14a4a"/>
+    <p:sldMasterId xmlns:r="http://schemas.openxmlformats.org/officeDocument/2006/relationships" id="2147483648" r:id="Ra31a789e3a774275"/>
   </p:sldMasterIdLst>
   <p:notesMasterIdLst>
-    <p:notesMasterId xmlns:r="http://schemas.openxmlformats.org/officeDocument/2006/relationships" r:id="R28ce04224e82456e"/>
+    <p:notesMasterId xmlns:r="http://schemas.openxmlformats.org/officeDocument/2006/relationships" r:id="R1958f3cadd364e0b"/>
   </p:notesMasterIdLst>
   <p:sldIdLst>
-    <p:sldId xmlns:r="http://schemas.openxmlformats.org/officeDocument/2006/relationships" id="256" r:id="R1e67c019f7844dbc"/>
+    <p:sldId xmlns:r="http://schemas.openxmlformats.org/officeDocument/2006/relationships" id="256" r:id="Rbb8b68d8e89e4259"/>
   </p:sldIdLst>
   <p:sldSz cx="9144000" cy="3429000"/>
   <p:notesSz cx="6858000" cy="9144000"/>
@@ -506,7 +506,7 @@
   </p:cSld>
   <p:clrMap bg1="lt1" tx1="dk1" bg2="lt2" tx2="dk2" accent1="accent1" accent2="accent2" accent3="accent3" accent4="accent4" accent5="accent5" accent6="accent6" hlink="hlink" folHlink="folHlink"/>
   <p:sldLayoutIdLst>
-    <p:sldLayoutId xmlns:r="http://schemas.openxmlformats.org/officeDocument/2006/relationships" id="2147483649" r:id="R740aae6372f94092"/>
+    <p:sldLayoutId xmlns:r="http://schemas.openxmlformats.org/officeDocument/2006/relationships" id="2147483649" r:id="R18e61033f02548ad"/>
   </p:sldLayoutIdLst>
   <p:txStyles>
     <p:titleStyle>
@@ -1054,14 +1054,14 @@
       </p:grpSpPr>
       <p:pic>
         <p:nvPicPr>
-          <p:cNvPr id="4" name=""/>
+          <p:cNvPr id="5" name=""/>
           <p:cNvPicPr>
             <a:picLocks xmlns:a="http://schemas.openxmlformats.org/drawingml/2006/main" noChangeAspect="1"/>
           </p:cNvPicPr>
           <p:nvPr/>
         </p:nvPicPr>
         <p:blipFill>
-          <a:blip xmlns:r="http://schemas.openxmlformats.org/officeDocument/2006/relationships" xmlns:a="http://schemas.openxmlformats.org/drawingml/2006/main" r:embed="Raf92b54b53014621"/>
+          <a:blip xmlns:r="http://schemas.openxmlformats.org/officeDocument/2006/relationships" xmlns:a="http://schemas.openxmlformats.org/drawingml/2006/main" r:embed="R813933590a0e4037"/>
           <a:stretch xmlns:a="http://schemas.openxmlformats.org/drawingml/2006/main"/>
         </p:blipFill>
         <p:spPr>
@@ -1108,6 +1108,7 @@
           <a:lstStyle xmlns:a="http://schemas.openxmlformats.org/drawingml/2006/main"/>
           <a:p xmlns:a="http://schemas.openxmlformats.org/drawingml/2006/main">
             <a:pPr algn="l">
+              <a:buNone/>
               <a:defRPr sz="8800" b="0">
                 <a:solidFill>
                   <a:srgbClr val="FFA3A0"/>
@@ -1147,8 +1148,8 @@
         </p:nvSpPr>
         <p:spPr>
           <a:xfrm xmlns:a="http://schemas.openxmlformats.org/drawingml/2006/main">
-            <a:off x="3638550" y="2095500"/>
-            <a:ext cx="5353050" cy="838200"/>
+            <a:off x="3705225" y="2095500"/>
+            <a:ext cx="5286375" cy="838200"/>
           </a:xfrm>
           <a:prstGeom xmlns:a="http://schemas.openxmlformats.org/drawingml/2006/main" prst="rect">
             <a:avLst/>
@@ -1165,7 +1166,8 @@
           <a:lstStyle xmlns:a="http://schemas.openxmlformats.org/drawingml/2006/main"/>
           <a:p xmlns:a="http://schemas.openxmlformats.org/drawingml/2006/main">
             <a:pPr algn="l">
-              <a:defRPr sz="4800" b="0">
+              <a:buNone/>
+              <a:defRPr sz="5130" b="0">
                 <a:solidFill>
                   <a:srgbClr val="000000"/>
                 </a:solidFill>
@@ -1175,7 +1177,7 @@
               </a:defRPr>
             </a:pPr>
             <a:r>
-              <a:rPr sz="4800" b="0">
+              <a:rPr sz="5130" b="0">
                 <a:solidFill>
                   <a:srgbClr val="000000"/>
                 </a:solidFill>

</xml_diff>